<commit_message>
feat: render copilot revision 08 with fitted labels and unchained factors
- drop arrows between independent access factors in the governance diagram
- re-render four voices on adapter 10 so labels stay inside their boxes

🎙️ - Generated by Copilot

Co-authored-by: Copilot <223556219+Copilot@users.noreply.github.com>
</commit_message>
<xml_diff>
--- a/projects/copilot/release/outputs/deck.pptx
+++ b/projects/copilot/release/outputs/deck.pptx
@@ -1314,7 +1314,7 @@
                   <a:srgbClr val="B4B7B5"/>
                 </a:solidFill>
               </a:rPr>
-              <a:t>copilot-2026-07-am-michael-kokoro-onnx</a:t>
+              <a:t>copilot-2026-08-am-michael-kokoro-onnx</a:t>
             </a:r>
           </a:p>
         </p:txBody>
@@ -2801,7 +2801,7 @@
                   <a:srgbClr val="B4B7B5"/>
                 </a:solidFill>
               </a:rPr>
-              <a:t>copilot-2026-07-am-michael-kokoro-onnx</a:t>
+              <a:t>copilot-2026-08-am-michael-kokoro-onnx</a:t>
             </a:r>
           </a:p>
         </p:txBody>

</xml_diff>

<commit_message>
feat: regenerate copilot with LF-stable release generation
- render four voices so release-verify passes on any checkout

🎙️ - Generated by Copilot

Co-authored-by: Copilot <223556219+Copilot@users.noreply.github.com>
</commit_message>
<xml_diff>
--- a/projects/copilot/release/outputs/deck.pptx
+++ b/projects/copilot/release/outputs/deck.pptx
@@ -1314,7 +1314,7 @@
                   <a:srgbClr val="B4B7B5"/>
                 </a:solidFill>
               </a:rPr>
-              <a:t>copilot-2026-08-am-michael-kokoro-onnx</a:t>
+              <a:t>copilot-2026-09-am-michael-kokoro-onnx</a:t>
             </a:r>
           </a:p>
         </p:txBody>
@@ -2801,7 +2801,7 @@
                   <a:srgbClr val="B4B7B5"/>
                 </a:solidFill>
               </a:rPr>
-              <a:t>copilot-2026-08-am-michael-kokoro-onnx</a:t>
+              <a:t>copilot-2026-09-am-michael-kokoro-onnx</a:t>
             </a:r>
           </a:p>
         </p:txBody>

</xml_diff>

<commit_message>
feat: regenerate copilot with its brand theme
- render four voices with the brand header band, palette and fonts

🎨 - Generated by Copilot

Co-authored-by: Copilot <223556219+Copilot@users.noreply.github.com>
</commit_message>
<xml_diff>
--- a/projects/copilot/release/outputs/deck.pptx
+++ b/projects/copilot/release/outputs/deck.pptx
@@ -18,6 +18,16 @@
     <a:defPPr>
       <a:defRPr lang="en-US"/>
     </a:defPPr>
+    <a:lvl1pPr algn="l" defTabSz="914400" marL="0" indent="0">
+      <a:defRPr sz="1800" kern="1200">
+        <a:solidFill>
+          <a:schemeClr val="tx1"/>
+        </a:solidFill>
+        <a:latin typeface="+mn-lt"/>
+        <a:ea typeface="+mn-ea"/>
+        <a:cs typeface="+mn-cs"/>
+      </a:defRPr>
+    </a:lvl1pPr>
   </p:defaultTextStyle>
 </p:presentation>
 </file>
@@ -1087,7 +1097,7 @@
     <p:bg>
       <p:bgPr>
         <a:solidFill>
-          <a:srgbClr val="101312"/>
+          <a:srgbClr val="F4F8FC"/>
         </a:solidFill>
         <a:effectLst/>
       </p:bgPr>
@@ -1101,20 +1111,20 @@
       <p:grpSpPr/>
       <p:sp>
         <p:nvSpPr>
-          <p:cNvPr id="2" name="Accent band"/>
+          <p:cNvPr id="2" name="Brand band"/>
           <p:cNvSpPr/>
           <p:nvPr/>
         </p:nvSpPr>
         <p:spPr>
           <a:xfrm>
             <a:off x="0" y="0"/>
-            <a:ext cx="12192000" cy="91440"/>
+            <a:ext cx="12192000" cy="502920"/>
           </a:xfrm>
           <a:prstGeom prst="rect">
             <a:avLst/>
           </a:prstGeom>
           <a:solidFill>
-            <a:srgbClr val="55C2B8"/>
+            <a:srgbClr val="091F2C"/>
           </a:solidFill>
           <a:ln>
             <a:noFill/>
@@ -1123,14 +1133,36 @@
       </p:sp>
       <p:sp>
         <p:nvSpPr>
-          <p:cNvPr id="3" name="Title"/>
-          <p:cNvSpPr txBox="1"/>
-          <p:nvPr/>
-        </p:nvSpPr>
-        <p:spPr>
-          <a:xfrm>
-            <a:off x="685800" y="900000"/>
-            <a:ext cx="10820400" cy="2000000"/>
+          <p:cNvPr id="3" name="Highlight rule"/>
+          <p:cNvSpPr/>
+          <p:nvPr/>
+        </p:nvSpPr>
+        <p:spPr>
+          <a:xfrm>
+            <a:off x="0" y="502920"/>
+            <a:ext cx="12192000" cy="45720"/>
+          </a:xfrm>
+          <a:prstGeom prst="rect">
+            <a:avLst/>
+          </a:prstGeom>
+          <a:solidFill>
+            <a:srgbClr val="50E6FF"/>
+          </a:solidFill>
+          <a:ln>
+            <a:noFill/>
+          </a:ln>
+        </p:spPr>
+      </p:sp>
+      <p:sp>
+        <p:nvSpPr>
+          <p:cNvPr id="4" name="Deck kicker"/>
+          <p:cNvSpPr txBox="1"/>
+          <p:nvPr/>
+        </p:nvSpPr>
+        <p:spPr>
+          <a:xfrm>
+            <a:off x="685800" y="0"/>
+            <a:ext cx="8400000" cy="502920"/>
           </a:xfrm>
           <a:prstGeom prst="rect">
             <a:avLst/>
@@ -1155,45 +1187,74 @@
               </a:spcAft>
             </a:pPr>
             <a:r>
-              <a:rPr lang="en-US" sz="3600" b="1">
-                <a:solidFill>
-                  <a:srgbClr val="F4F7F5"/>
-                </a:solidFill>
-              </a:rPr>
-              <a:t>Copilot:</a:t>
-            </a:r>
-            <a:r>
-              <a:rPr lang="en-US" sz="3600" b="1">
-                <a:solidFill>
-                  <a:srgbClr val="55C2B8"/>
-                </a:solidFill>
-              </a:rPr>
-              <a:t> choose the right AI assistant for the job</a:t>
-            </a:r>
-          </a:p>
-        </p:txBody>
-      </p:sp>
-      <p:sp>
-        <p:nvSpPr>
-          <p:cNvPr id="4" name="Summary"/>
-          <p:cNvSpPr txBox="1"/>
-          <p:nvPr/>
-        </p:nvSpPr>
-        <p:spPr>
-          <a:xfrm>
-            <a:off x="685800" y="3000000"/>
-            <a:ext cx="9600000" cy="1400000"/>
-          </a:xfrm>
-          <a:prstGeom prst="rect">
-            <a:avLst/>
-          </a:prstGeom>
-          <a:noFill/>
-          <a:ln>
-            <a:noFill/>
-          </a:ln>
-        </p:spPr>
-        <p:txBody>
-          <a:bodyPr wrap="square" lIns="182880" tIns="91440" rIns="182880" bIns="91440" anchor="t">
+              <a:rPr lang="en-US" sz="1100" b="1" cap="all" spc="120">
+                <a:solidFill>
+                  <a:srgbClr val="FFFFFF"/>
+                </a:solidFill>
+              </a:rPr>
+              <a:t>Copilot</a:t>
+            </a:r>
+          </a:p>
+        </p:txBody>
+      </p:sp>
+      <p:sp>
+        <p:nvSpPr>
+          <p:cNvPr id="5" name="Slide number"/>
+          <p:cNvSpPr txBox="1"/>
+          <p:nvPr/>
+        </p:nvSpPr>
+        <p:spPr>
+          <a:xfrm>
+            <a:off x="9100000" y="0"/>
+            <a:ext cx="2406400" cy="502920"/>
+          </a:xfrm>
+          <a:prstGeom prst="rect">
+            <a:avLst/>
+          </a:prstGeom>
+          <a:noFill/>
+          <a:ln>
+            <a:noFill/>
+          </a:ln>
+        </p:spPr>
+        <p:txBody>
+          <a:bodyPr wrap="square" lIns="182880" tIns="91440" rIns="182880" bIns="91440" anchor="ctr">
+            <a:normAutofit/>
+          </a:bodyPr>
+          <a:lstStyle/>
+          <a:p>
+            <a:pPr algn="r"/>
+            <a:r>
+              <a:rPr lang="en-US" sz="1100" b="1" cap="all" spc="120">
+                <a:solidFill>
+                  <a:srgbClr val="BAC0C4"/>
+                </a:solidFill>
+              </a:rPr>
+              <a:t>1 / 6</a:t>
+            </a:r>
+          </a:p>
+        </p:txBody>
+      </p:sp>
+      <p:sp>
+        <p:nvSpPr>
+          <p:cNvPr id="6" name="Title"/>
+          <p:cNvSpPr txBox="1"/>
+          <p:nvPr/>
+        </p:nvSpPr>
+        <p:spPr>
+          <a:xfrm>
+            <a:off x="685800" y="1100000"/>
+            <a:ext cx="10820400" cy="2000000"/>
+          </a:xfrm>
+          <a:prstGeom prst="rect">
+            <a:avLst/>
+          </a:prstGeom>
+          <a:noFill/>
+          <a:ln>
+            <a:noFill/>
+          </a:ln>
+        </p:spPr>
+        <p:txBody>
+          <a:bodyPr wrap="square" lIns="182880" tIns="91440" rIns="182880" bIns="91440" anchor="ctr">
             <a:normAutofit/>
           </a:bodyPr>
           <a:lstStyle/>
@@ -1207,43 +1268,47 @@
               </a:spcAft>
             </a:pPr>
             <a:r>
-              <a:rPr lang="en-US" sz="1800">
-                <a:solidFill>
-                  <a:srgbClr val="B4B7B5"/>
-                </a:solidFill>
-              </a:rPr>
-              <a:t>Bottom line: Copilot is a family, not one tool; choose Chat, Microsoft 365, GitHub, or Studio by job, then verify access, licensing, and grounding.</a:t>
-            </a:r>
-          </a:p>
-        </p:txBody>
-      </p:sp>
-      <p:sp>
-        <p:nvSpPr>
-          <p:cNvPr id="5" name="Decision"/>
-          <p:cNvSpPr/>
-          <p:nvPr/>
-        </p:nvSpPr>
-        <p:spPr>
-          <a:xfrm>
-            <a:off x="685800" y="4500000"/>
-            <a:ext cx="10820400" cy="1000000"/>
-          </a:xfrm>
-          <a:prstGeom prst="roundRect">
-            <a:avLst>
-              <a:gd name="adj" fmla="val 9000"/>
-            </a:avLst>
-          </a:prstGeom>
-          <a:solidFill>
-            <a:srgbClr val="1B2F2D"/>
-          </a:solidFill>
-          <a:ln w="12700">
-            <a:solidFill>
-              <a:srgbClr val="55C2B8"/>
-            </a:solidFill>
-          </a:ln>
-        </p:spPr>
-        <p:txBody>
-          <a:bodyPr wrap="square" lIns="182880" tIns="91440" rIns="182880" bIns="91440" anchor="ctr">
+              <a:rPr lang="en-US" sz="3600" b="1">
+                <a:solidFill>
+                  <a:srgbClr val="071923"/>
+                </a:solidFill>
+                <a:latin typeface="+mj-lt"/>
+              </a:rPr>
+              <a:t>Copilot:</a:t>
+            </a:r>
+            <a:r>
+              <a:rPr lang="en-US" sz="3600" b="1">
+                <a:solidFill>
+                  <a:srgbClr val="006EC3"/>
+                </a:solidFill>
+                <a:latin typeface="+mj-lt"/>
+              </a:rPr>
+              <a:t> choose the right AI assistant for the job</a:t>
+            </a:r>
+          </a:p>
+        </p:txBody>
+      </p:sp>
+      <p:sp>
+        <p:nvSpPr>
+          <p:cNvPr id="7" name="Summary"/>
+          <p:cNvSpPr txBox="1"/>
+          <p:nvPr/>
+        </p:nvSpPr>
+        <p:spPr>
+          <a:xfrm>
+            <a:off x="685800" y="3150000"/>
+            <a:ext cx="9600000" cy="1400000"/>
+          </a:xfrm>
+          <a:prstGeom prst="rect">
+            <a:avLst/>
+          </a:prstGeom>
+          <a:noFill/>
+          <a:ln>
+            <a:noFill/>
+          </a:ln>
+        </p:spPr>
+        <p:txBody>
+          <a:bodyPr wrap="square" lIns="182880" tIns="91440" rIns="182880" bIns="91440" anchor="t">
             <a:normAutofit/>
           </a:bodyPr>
           <a:lstStyle/>
@@ -1257,45 +1322,43 @@
               </a:spcAft>
             </a:pPr>
             <a:r>
-              <a:rPr lang="en-US" sz="1400" b="1">
-                <a:solidFill>
-                  <a:srgbClr val="55C2B8"/>
-                </a:solidFill>
-              </a:rPr>
-              <a:t>DECISION  </a:t>
-            </a:r>
-            <a:r>
-              <a:rPr lang="en-US" sz="2000" b="1">
-                <a:solidFill>
-                  <a:srgbClr val="F4F7F5"/>
-                </a:solidFill>
-              </a:rPr>
-              <a:t>Choose by job; verify access, licensing, grounding, and output scope.</a:t>
-            </a:r>
-          </a:p>
-        </p:txBody>
-      </p:sp>
-      <p:sp>
-        <p:nvSpPr>
-          <p:cNvPr id="6" name="Footer"/>
-          <p:cNvSpPr txBox="1"/>
-          <p:nvPr/>
-        </p:nvSpPr>
-        <p:spPr>
-          <a:xfrm>
-            <a:off x="685800" y="6250000"/>
-            <a:ext cx="9400000" cy="420000"/>
-          </a:xfrm>
-          <a:prstGeom prst="rect">
-            <a:avLst/>
-          </a:prstGeom>
-          <a:noFill/>
-          <a:ln>
-            <a:noFill/>
-          </a:ln>
-        </p:spPr>
-        <p:txBody>
-          <a:bodyPr wrap="square" lIns="182880" tIns="91440" rIns="182880" bIns="91440" anchor="t">
+              <a:rPr lang="en-US" sz="1800">
+                <a:solidFill>
+                  <a:srgbClr val="626C71"/>
+                </a:solidFill>
+              </a:rPr>
+              <a:t>Bottom line: Copilot is a family, not one tool; choose Chat, Microsoft 365, GitHub, or Studio by job, then verify access, licensing, and grounding.</a:t>
+            </a:r>
+          </a:p>
+        </p:txBody>
+      </p:sp>
+      <p:sp>
+        <p:nvSpPr>
+          <p:cNvPr id="8" name="Decision"/>
+          <p:cNvSpPr/>
+          <p:nvPr/>
+        </p:nvSpPr>
+        <p:spPr>
+          <a:xfrm>
+            <a:off x="685800" y="4650000"/>
+            <a:ext cx="10820400" cy="1000000"/>
+          </a:xfrm>
+          <a:prstGeom prst="roundRect">
+            <a:avLst>
+              <a:gd name="adj" fmla="val 6000"/>
+            </a:avLst>
+          </a:prstGeom>
+          <a:solidFill>
+            <a:srgbClr val="E5FBFF"/>
+          </a:solidFill>
+          <a:ln w="12700">
+            <a:solidFill>
+              <a:srgbClr val="328F9E"/>
+            </a:solidFill>
+          </a:ln>
+        </p:spPr>
+        <p:txBody>
+          <a:bodyPr wrap="square" lIns="182880" tIns="91440" rIns="182880" bIns="91440" anchor="ctr">
             <a:normAutofit/>
           </a:bodyPr>
           <a:lstStyle/>
@@ -1309,26 +1372,34 @@
               </a:spcAft>
             </a:pPr>
             <a:r>
-              <a:rPr lang="en-US" sz="1000">
-                <a:solidFill>
-                  <a:srgbClr val="B4B7B5"/>
-                </a:solidFill>
-              </a:rPr>
-              <a:t>copilot-2026-09-am-michael-kokoro-onnx</a:t>
-            </a:r>
-          </a:p>
-        </p:txBody>
-      </p:sp>
-      <p:sp>
-        <p:nvSpPr>
-          <p:cNvPr id="7" name="Slide number"/>
-          <p:cNvSpPr txBox="1"/>
-          <p:nvPr/>
-        </p:nvSpPr>
-        <p:spPr>
-          <a:xfrm>
-            <a:off x="10100000" y="6250000"/>
-            <a:ext cx="1400000" cy="420000"/>
+              <a:rPr lang="en-US" sz="1400" b="1">
+                <a:solidFill>
+                  <a:srgbClr val="006EC3"/>
+                </a:solidFill>
+              </a:rPr>
+              <a:t>DECISION  </a:t>
+            </a:r>
+            <a:r>
+              <a:rPr lang="en-US" sz="2000" b="1">
+                <a:solidFill>
+                  <a:srgbClr val="071923"/>
+                </a:solidFill>
+              </a:rPr>
+              <a:t>Choose by job; verify access, licensing, grounding, and output scope.</a:t>
+            </a:r>
+          </a:p>
+        </p:txBody>
+      </p:sp>
+      <p:sp>
+        <p:nvSpPr>
+          <p:cNvPr id="9" name="Footer"/>
+          <p:cNvSpPr txBox="1"/>
+          <p:nvPr/>
+        </p:nvSpPr>
+        <p:spPr>
+          <a:xfrm>
+            <a:off x="685800" y="6250000"/>
+            <a:ext cx="10820400" cy="420000"/>
           </a:xfrm>
           <a:prstGeom prst="rect">
             <a:avLst/>
@@ -1344,14 +1415,21 @@
           </a:bodyPr>
           <a:lstStyle/>
           <a:p>
-            <a:pPr algn="r"/>
+            <a:pPr algn="l">
+              <a:lnSpc>
+                <a:spcPct val="105000"/>
+              </a:lnSpc>
+              <a:spcAft>
+                <a:spcPts val="0"/>
+              </a:spcAft>
+            </a:pPr>
             <a:r>
               <a:rPr lang="en-US" sz="1000">
                 <a:solidFill>
-                  <a:srgbClr val="B4B7B5"/>
-                </a:solidFill>
-              </a:rPr>
-              <a:t>1 / 6</a:t>
+                  <a:srgbClr val="626C71"/>
+                </a:solidFill>
+              </a:rPr>
+              <a:t>copilot-2026-10-am-michael-kokoro-onnx</a:t>
             </a:r>
           </a:p>
         </p:txBody>
@@ -1370,7 +1448,7 @@
     <p:bg>
       <p:bgPr>
         <a:solidFill>
-          <a:srgbClr val="101312"/>
+          <a:srgbClr val="F4F8FC"/>
         </a:solidFill>
         <a:effectLst/>
       </p:bgPr>
@@ -1384,20 +1462,20 @@
       <p:grpSpPr/>
       <p:sp>
         <p:nvSpPr>
-          <p:cNvPr id="2" name="Accent band"/>
+          <p:cNvPr id="2" name="Brand band"/>
           <p:cNvSpPr/>
           <p:nvPr/>
         </p:nvSpPr>
         <p:spPr>
           <a:xfrm>
             <a:off x="0" y="0"/>
-            <a:ext cx="12192000" cy="91440"/>
+            <a:ext cx="12192000" cy="502920"/>
           </a:xfrm>
           <a:prstGeom prst="rect">
             <a:avLst/>
           </a:prstGeom>
           <a:solidFill>
-            <a:srgbClr val="55C2B8"/>
+            <a:srgbClr val="091F2C"/>
           </a:solidFill>
           <a:ln>
             <a:noFill/>
@@ -1406,14 +1484,36 @@
       </p:sp>
       <p:sp>
         <p:nvSpPr>
-          <p:cNvPr id="3" name="Title"/>
-          <p:cNvSpPr txBox="1"/>
-          <p:nvPr/>
-        </p:nvSpPr>
-        <p:spPr>
-          <a:xfrm>
-            <a:off x="685800" y="420000"/>
-            <a:ext cx="10820400" cy="1150000"/>
+          <p:cNvPr id="3" name="Highlight rule"/>
+          <p:cNvSpPr/>
+          <p:nvPr/>
+        </p:nvSpPr>
+        <p:spPr>
+          <a:xfrm>
+            <a:off x="0" y="502920"/>
+            <a:ext cx="12192000" cy="45720"/>
+          </a:xfrm>
+          <a:prstGeom prst="rect">
+            <a:avLst/>
+          </a:prstGeom>
+          <a:solidFill>
+            <a:srgbClr val="50E6FF"/>
+          </a:solidFill>
+          <a:ln>
+            <a:noFill/>
+          </a:ln>
+        </p:spPr>
+      </p:sp>
+      <p:sp>
+        <p:nvSpPr>
+          <p:cNvPr id="4" name="Deck kicker"/>
+          <p:cNvSpPr txBox="1"/>
+          <p:nvPr/>
+        </p:nvSpPr>
+        <p:spPr>
+          <a:xfrm>
+            <a:off x="685800" y="0"/>
+            <a:ext cx="8400000" cy="502920"/>
           </a:xfrm>
           <a:prstGeom prst="rect">
             <a:avLst/>
@@ -1438,45 +1538,74 @@
               </a:spcAft>
             </a:pPr>
             <a:r>
-              <a:rPr lang="en-US" sz="2900" b="1">
-                <a:solidFill>
-                  <a:srgbClr val="F4F7F5"/>
-                </a:solidFill>
-              </a:rPr>
-              <a:t>1.</a:t>
-            </a:r>
-            <a:r>
-              <a:rPr lang="en-US" sz="2900" b="1">
-                <a:solidFill>
-                  <a:srgbClr val="55C2B8"/>
-                </a:solidFill>
-              </a:rPr>
-              <a:t> Choose by job</a:t>
-            </a:r>
-          </a:p>
-        </p:txBody>
-      </p:sp>
-      <p:sp>
-        <p:nvSpPr>
-          <p:cNvPr id="4" name="Body"/>
-          <p:cNvSpPr txBox="1"/>
-          <p:nvPr/>
-        </p:nvSpPr>
-        <p:spPr>
-          <a:xfrm>
-            <a:off x="685800" y="1750000"/>
-            <a:ext cx="3900000" cy="3900000"/>
-          </a:xfrm>
-          <a:prstGeom prst="rect">
-            <a:avLst/>
-          </a:prstGeom>
-          <a:noFill/>
-          <a:ln>
-            <a:noFill/>
-          </a:ln>
-        </p:spPr>
-        <p:txBody>
-          <a:bodyPr wrap="square" lIns="182880" tIns="91440" rIns="182880" bIns="91440" anchor="t">
+              <a:rPr lang="en-US" sz="1100" b="1" cap="all" spc="120">
+                <a:solidFill>
+                  <a:srgbClr val="FFFFFF"/>
+                </a:solidFill>
+              </a:rPr>
+              <a:t>Copilot</a:t>
+            </a:r>
+          </a:p>
+        </p:txBody>
+      </p:sp>
+      <p:sp>
+        <p:nvSpPr>
+          <p:cNvPr id="5" name="Slide number"/>
+          <p:cNvSpPr txBox="1"/>
+          <p:nvPr/>
+        </p:nvSpPr>
+        <p:spPr>
+          <a:xfrm>
+            <a:off x="9100000" y="0"/>
+            <a:ext cx="2406400" cy="502920"/>
+          </a:xfrm>
+          <a:prstGeom prst="rect">
+            <a:avLst/>
+          </a:prstGeom>
+          <a:noFill/>
+          <a:ln>
+            <a:noFill/>
+          </a:ln>
+        </p:spPr>
+        <p:txBody>
+          <a:bodyPr wrap="square" lIns="182880" tIns="91440" rIns="182880" bIns="91440" anchor="ctr">
+            <a:normAutofit/>
+          </a:bodyPr>
+          <a:lstStyle/>
+          <a:p>
+            <a:pPr algn="r"/>
+            <a:r>
+              <a:rPr lang="en-US" sz="1100" b="1" cap="all" spc="120">
+                <a:solidFill>
+                  <a:srgbClr val="BAC0C4"/>
+                </a:solidFill>
+              </a:rPr>
+              <a:t>2 / 6</a:t>
+            </a:r>
+          </a:p>
+        </p:txBody>
+      </p:sp>
+      <p:sp>
+        <p:nvSpPr>
+          <p:cNvPr id="6" name="Title"/>
+          <p:cNvSpPr txBox="1"/>
+          <p:nvPr/>
+        </p:nvSpPr>
+        <p:spPr>
+          <a:xfrm>
+            <a:off x="685800" y="700000"/>
+            <a:ext cx="10820400" cy="1150000"/>
+          </a:xfrm>
+          <a:prstGeom prst="rect">
+            <a:avLst/>
+          </a:prstGeom>
+          <a:noFill/>
+          <a:ln>
+            <a:noFill/>
+          </a:ln>
+        </p:spPr>
+        <p:txBody>
+          <a:bodyPr wrap="square" lIns="182880" tIns="91440" rIns="182880" bIns="91440" anchor="ctr">
             <a:normAutofit/>
           </a:bodyPr>
           <a:lstStyle/>
@@ -1490,77 +1619,36 @@
               </a:spcAft>
             </a:pPr>
             <a:r>
-              <a:rPr lang="en-US" sz="2400">
-                <a:solidFill>
-                  <a:srgbClr val="F4F7F5"/>
-                </a:solidFill>
-              </a:rPr>
-              <a:t>Copilot Chat fits research and drafting. It can summarize web information, rewrite content, analyze files, create images, use agents, and ask supported work questions.</a:t>
-            </a:r>
-          </a:p>
-        </p:txBody>
-      </p:sp>
-      <p:sp>
-        <p:nvSpPr>
-          <p:cNvPr id="5" name="Accent rule"/>
-          <p:cNvSpPr/>
-          <p:nvPr/>
-        </p:nvSpPr>
-        <p:spPr>
-          <a:xfrm>
-            <a:off x="548640" y="1800000"/>
-            <a:ext cx="45720" cy="3800000"/>
-          </a:xfrm>
-          <a:prstGeom prst="rect">
-            <a:avLst/>
-          </a:prstGeom>
-          <a:solidFill>
-            <a:srgbClr val="55C2B8"/>
-          </a:solidFill>
-          <a:ln>
-            <a:noFill/>
-          </a:ln>
-        </p:spPr>
-      </p:sp>
-      <p:pic>
-        <p:nvPicPr>
-          <p:cNvPr id="6" name="Asset visual-choose-by-job" descr="Route Copilot choices by the job the leader needs done. (mermaid diagram)"/>
-          <p:cNvPicPr>
-            <a:picLocks noChangeAspect="1"/>
-          </p:cNvPicPr>
-          <p:nvPr/>
-        </p:nvPicPr>
-        <p:blipFill>
-          <a:blip r:embed="rIdImage1"/>
-          <a:stretch>
-            <a:fillRect/>
-          </a:stretch>
-        </p:blipFill>
-        <p:spPr>
-          <a:xfrm>
-            <a:off x="5000000" y="2021875"/>
-            <a:ext cx="6500000" cy="3656250"/>
-          </a:xfrm>
-          <a:prstGeom prst="rect">
-            <a:avLst/>
-          </a:prstGeom>
-          <a:ln>
-            <a:solidFill>
-              <a:srgbClr val="D9D9D9"/>
-            </a:solidFill>
-          </a:ln>
-        </p:spPr>
-      </p:pic>
-      <p:sp>
-        <p:nvSpPr>
-          <p:cNvPr id="7" name="Footer"/>
-          <p:cNvSpPr txBox="1"/>
-          <p:nvPr/>
-        </p:nvSpPr>
-        <p:spPr>
-          <a:xfrm>
-            <a:off x="685800" y="6250000"/>
-            <a:ext cx="9400000" cy="420000"/>
+              <a:rPr lang="en-US" sz="2900" b="1">
+                <a:solidFill>
+                  <a:srgbClr val="071923"/>
+                </a:solidFill>
+                <a:latin typeface="+mj-lt"/>
+              </a:rPr>
+              <a:t>1.</a:t>
+            </a:r>
+            <a:r>
+              <a:rPr lang="en-US" sz="2900" b="1">
+                <a:solidFill>
+                  <a:srgbClr val="006EC3"/>
+                </a:solidFill>
+                <a:latin typeface="+mj-lt"/>
+              </a:rPr>
+              <a:t> Choose by job</a:t>
+            </a:r>
+          </a:p>
+        </p:txBody>
+      </p:sp>
+      <p:sp>
+        <p:nvSpPr>
+          <p:cNvPr id="7" name="Body"/>
+          <p:cNvSpPr txBox="1"/>
+          <p:nvPr/>
+        </p:nvSpPr>
+        <p:spPr>
+          <a:xfrm>
+            <a:off x="685800" y="1950000"/>
+            <a:ext cx="3900000" cy="3900000"/>
           </a:xfrm>
           <a:prstGeom prst="rect">
             <a:avLst/>
@@ -1585,26 +1673,77 @@
               </a:spcAft>
             </a:pPr>
             <a:r>
-              <a:rPr lang="en-US" sz="1000">
-                <a:solidFill>
-                  <a:srgbClr val="B4B7B5"/>
-                </a:solidFill>
-              </a:rPr>
-              <a:t>Sources: Overview of Microsoft Copilot Chat  ·  What is Microsoft Copilot?  ·  GitHub Copilot · Your AI coding agent · GitHub  ·  +1 more</a:t>
-            </a:r>
-          </a:p>
-        </p:txBody>
-      </p:sp>
-      <p:sp>
-        <p:nvSpPr>
-          <p:cNvPr id="8" name="Slide number"/>
-          <p:cNvSpPr txBox="1"/>
-          <p:nvPr/>
-        </p:nvSpPr>
-        <p:spPr>
-          <a:xfrm>
-            <a:off x="10100000" y="6250000"/>
-            <a:ext cx="1400000" cy="420000"/>
+              <a:rPr lang="en-US" sz="2400">
+                <a:solidFill>
+                  <a:srgbClr val="071923"/>
+                </a:solidFill>
+              </a:rPr>
+              <a:t>Copilot Chat fits research and drafting. It can summarize web information, rewrite content, analyze files, create images, use agents, and ask supported work questions.</a:t>
+            </a:r>
+          </a:p>
+        </p:txBody>
+      </p:sp>
+      <p:sp>
+        <p:nvSpPr>
+          <p:cNvPr id="8" name="Accent rule"/>
+          <p:cNvSpPr/>
+          <p:nvPr/>
+        </p:nvSpPr>
+        <p:spPr>
+          <a:xfrm>
+            <a:off x="548640" y="2000000"/>
+            <a:ext cx="45720" cy="3800000"/>
+          </a:xfrm>
+          <a:prstGeom prst="rect">
+            <a:avLst/>
+          </a:prstGeom>
+          <a:solidFill>
+            <a:srgbClr val="006EC3"/>
+          </a:solidFill>
+          <a:ln>
+            <a:noFill/>
+          </a:ln>
+        </p:spPr>
+      </p:sp>
+      <p:pic>
+        <p:nvPicPr>
+          <p:cNvPr id="9" name="Asset visual-choose-by-job" descr="Route Copilot choices by the job the leader needs done. (mermaid diagram)"/>
+          <p:cNvPicPr>
+            <a:picLocks noChangeAspect="1"/>
+          </p:cNvPicPr>
+          <p:nvPr/>
+        </p:nvPicPr>
+        <p:blipFill>
+          <a:blip r:embed="rIdImage1"/>
+          <a:stretch>
+            <a:fillRect/>
+          </a:stretch>
+        </p:blipFill>
+        <p:spPr>
+          <a:xfrm>
+            <a:off x="5000000" y="2221875"/>
+            <a:ext cx="6500000" cy="3656250"/>
+          </a:xfrm>
+          <a:prstGeom prst="rect">
+            <a:avLst/>
+          </a:prstGeom>
+          <a:ln>
+            <a:solidFill>
+              <a:srgbClr val="D9D9D9"/>
+            </a:solidFill>
+          </a:ln>
+        </p:spPr>
+      </p:pic>
+      <p:sp>
+        <p:nvSpPr>
+          <p:cNvPr id="10" name="Footer"/>
+          <p:cNvSpPr txBox="1"/>
+          <p:nvPr/>
+        </p:nvSpPr>
+        <p:spPr>
+          <a:xfrm>
+            <a:off x="685800" y="6250000"/>
+            <a:ext cx="10820400" cy="420000"/>
           </a:xfrm>
           <a:prstGeom prst="rect">
             <a:avLst/>
@@ -1620,14 +1759,21 @@
           </a:bodyPr>
           <a:lstStyle/>
           <a:p>
-            <a:pPr algn="r"/>
+            <a:pPr algn="l">
+              <a:lnSpc>
+                <a:spcPct val="105000"/>
+              </a:lnSpc>
+              <a:spcAft>
+                <a:spcPts val="0"/>
+              </a:spcAft>
+            </a:pPr>
             <a:r>
               <a:rPr lang="en-US" sz="1000">
                 <a:solidFill>
-                  <a:srgbClr val="B4B7B5"/>
-                </a:solidFill>
-              </a:rPr>
-              <a:t>2 / 6</a:t>
+                  <a:srgbClr val="626C71"/>
+                </a:solidFill>
+              </a:rPr>
+              <a:t>Sources: Overview of Microsoft Copilot Chat  ·  What is Microsoft Copilot?  ·  GitHub Copilot · Your AI coding agent · GitHub  ·  +1 more</a:t>
             </a:r>
           </a:p>
         </p:txBody>
@@ -1646,7 +1792,7 @@
     <p:bg>
       <p:bgPr>
         <a:solidFill>
-          <a:srgbClr val="101312"/>
+          <a:srgbClr val="F4F8FC"/>
         </a:solidFill>
         <a:effectLst/>
       </p:bgPr>
@@ -1660,20 +1806,20 @@
       <p:grpSpPr/>
       <p:sp>
         <p:nvSpPr>
-          <p:cNvPr id="2" name="Accent band"/>
+          <p:cNvPr id="2" name="Brand band"/>
           <p:cNvSpPr/>
           <p:nvPr/>
         </p:nvSpPr>
         <p:spPr>
           <a:xfrm>
             <a:off x="0" y="0"/>
-            <a:ext cx="12192000" cy="91440"/>
+            <a:ext cx="12192000" cy="502920"/>
           </a:xfrm>
           <a:prstGeom prst="rect">
             <a:avLst/>
           </a:prstGeom>
           <a:solidFill>
-            <a:srgbClr val="55C2B8"/>
+            <a:srgbClr val="091F2C"/>
           </a:solidFill>
           <a:ln>
             <a:noFill/>
@@ -1682,14 +1828,36 @@
       </p:sp>
       <p:sp>
         <p:nvSpPr>
-          <p:cNvPr id="3" name="Title"/>
-          <p:cNvSpPr txBox="1"/>
-          <p:nvPr/>
-        </p:nvSpPr>
-        <p:spPr>
-          <a:xfrm>
-            <a:off x="685800" y="420000"/>
-            <a:ext cx="10820400" cy="1150000"/>
+          <p:cNvPr id="3" name="Highlight rule"/>
+          <p:cNvSpPr/>
+          <p:nvPr/>
+        </p:nvSpPr>
+        <p:spPr>
+          <a:xfrm>
+            <a:off x="0" y="502920"/>
+            <a:ext cx="12192000" cy="45720"/>
+          </a:xfrm>
+          <a:prstGeom prst="rect">
+            <a:avLst/>
+          </a:prstGeom>
+          <a:solidFill>
+            <a:srgbClr val="50E6FF"/>
+          </a:solidFill>
+          <a:ln>
+            <a:noFill/>
+          </a:ln>
+        </p:spPr>
+      </p:sp>
+      <p:sp>
+        <p:nvSpPr>
+          <p:cNvPr id="4" name="Deck kicker"/>
+          <p:cNvSpPr txBox="1"/>
+          <p:nvPr/>
+        </p:nvSpPr>
+        <p:spPr>
+          <a:xfrm>
+            <a:off x="685800" y="0"/>
+            <a:ext cx="8400000" cy="502920"/>
           </a:xfrm>
           <a:prstGeom prst="rect">
             <a:avLst/>
@@ -1714,45 +1882,74 @@
               </a:spcAft>
             </a:pPr>
             <a:r>
-              <a:rPr lang="en-US" sz="2900" b="1">
-                <a:solidFill>
-                  <a:srgbClr val="F4F7F5"/>
-                </a:solidFill>
-              </a:rPr>
-              <a:t>2.</a:t>
-            </a:r>
-            <a:r>
-              <a:rPr lang="en-US" sz="2900" b="1">
-                <a:solidFill>
-                  <a:srgbClr val="55C2B8"/>
-                </a:solidFill>
-              </a:rPr>
-              <a:t> Govern access</a:t>
-            </a:r>
-          </a:p>
-        </p:txBody>
-      </p:sp>
-      <p:sp>
-        <p:nvSpPr>
-          <p:cNvPr id="4" name="Body"/>
-          <p:cNvSpPr txBox="1"/>
-          <p:nvPr/>
-        </p:nvSpPr>
-        <p:spPr>
-          <a:xfrm>
-            <a:off x="685800" y="1750000"/>
-            <a:ext cx="3900000" cy="3900000"/>
-          </a:xfrm>
-          <a:prstGeom prst="rect">
-            <a:avLst/>
-          </a:prstGeom>
-          <a:noFill/>
-          <a:ln>
-            <a:noFill/>
-          </a:ln>
-        </p:spPr>
-        <p:txBody>
-          <a:bodyPr wrap="square" lIns="182880" tIns="91440" rIns="182880" bIns="91440" anchor="t">
+              <a:rPr lang="en-US" sz="1100" b="1" cap="all" spc="120">
+                <a:solidFill>
+                  <a:srgbClr val="FFFFFF"/>
+                </a:solidFill>
+              </a:rPr>
+              <a:t>Copilot</a:t>
+            </a:r>
+          </a:p>
+        </p:txBody>
+      </p:sp>
+      <p:sp>
+        <p:nvSpPr>
+          <p:cNvPr id="5" name="Slide number"/>
+          <p:cNvSpPr txBox="1"/>
+          <p:nvPr/>
+        </p:nvSpPr>
+        <p:spPr>
+          <a:xfrm>
+            <a:off x="9100000" y="0"/>
+            <a:ext cx="2406400" cy="502920"/>
+          </a:xfrm>
+          <a:prstGeom prst="rect">
+            <a:avLst/>
+          </a:prstGeom>
+          <a:noFill/>
+          <a:ln>
+            <a:noFill/>
+          </a:ln>
+        </p:spPr>
+        <p:txBody>
+          <a:bodyPr wrap="square" lIns="182880" tIns="91440" rIns="182880" bIns="91440" anchor="ctr">
+            <a:normAutofit/>
+          </a:bodyPr>
+          <a:lstStyle/>
+          <a:p>
+            <a:pPr algn="r"/>
+            <a:r>
+              <a:rPr lang="en-US" sz="1100" b="1" cap="all" spc="120">
+                <a:solidFill>
+                  <a:srgbClr val="BAC0C4"/>
+                </a:solidFill>
+              </a:rPr>
+              <a:t>3 / 6</a:t>
+            </a:r>
+          </a:p>
+        </p:txBody>
+      </p:sp>
+      <p:sp>
+        <p:nvSpPr>
+          <p:cNvPr id="6" name="Title"/>
+          <p:cNvSpPr txBox="1"/>
+          <p:nvPr/>
+        </p:nvSpPr>
+        <p:spPr>
+          <a:xfrm>
+            <a:off x="685800" y="700000"/>
+            <a:ext cx="10820400" cy="1150000"/>
+          </a:xfrm>
+          <a:prstGeom prst="rect">
+            <a:avLst/>
+          </a:prstGeom>
+          <a:noFill/>
+          <a:ln>
+            <a:noFill/>
+          </a:ln>
+        </p:spPr>
+        <p:txBody>
+          <a:bodyPr wrap="square" lIns="182880" tIns="91440" rIns="182880" bIns="91440" anchor="ctr">
             <a:normAutofit/>
           </a:bodyPr>
           <a:lstStyle/>
@@ -1766,77 +1963,36 @@
               </a:spcAft>
             </a:pPr>
             <a:r>
-              <a:rPr lang="en-US" sz="2500">
-                <a:solidFill>
-                  <a:srgbClr val="F4F7F5"/>
-                </a:solidFill>
-              </a:rPr>
-              <a:t>Microsoft 365 Copilot brings AI into work apps. Grounding, user permissions, compliance controls and license level shape what it can answer for each person.</a:t>
-            </a:r>
-          </a:p>
-        </p:txBody>
-      </p:sp>
-      <p:sp>
-        <p:nvSpPr>
-          <p:cNvPr id="5" name="Accent rule"/>
-          <p:cNvSpPr/>
-          <p:nvPr/>
-        </p:nvSpPr>
-        <p:spPr>
-          <a:xfrm>
-            <a:off x="548640" y="1800000"/>
-            <a:ext cx="45720" cy="3800000"/>
-          </a:xfrm>
-          <a:prstGeom prst="rect">
-            <a:avLst/>
-          </a:prstGeom>
-          <a:solidFill>
-            <a:srgbClr val="55C2B8"/>
-          </a:solidFill>
-          <a:ln>
-            <a:noFill/>
-          </a:ln>
-        </p:spPr>
-      </p:sp>
-      <p:pic>
-        <p:nvPicPr>
-          <p:cNvPr id="6" name="Asset visual-govern-access" descr="Access governance makes the permitted information boundary explicit. (excalidraw diagram)"/>
-          <p:cNvPicPr>
-            <a:picLocks noChangeAspect="1"/>
-          </p:cNvPicPr>
-          <p:nvPr/>
-        </p:nvPicPr>
-        <p:blipFill>
-          <a:blip r:embed="rIdImage1"/>
-          <a:stretch>
-            <a:fillRect/>
-          </a:stretch>
-        </p:blipFill>
-        <p:spPr>
-          <a:xfrm>
-            <a:off x="5000000" y="2021875"/>
-            <a:ext cx="6500000" cy="3656250"/>
-          </a:xfrm>
-          <a:prstGeom prst="rect">
-            <a:avLst/>
-          </a:prstGeom>
-          <a:ln>
-            <a:solidFill>
-              <a:srgbClr val="D9D9D9"/>
-            </a:solidFill>
-          </a:ln>
-        </p:spPr>
-      </p:pic>
-      <p:sp>
-        <p:nvSpPr>
-          <p:cNvPr id="7" name="Footer"/>
-          <p:cNvSpPr txBox="1"/>
-          <p:nvPr/>
-        </p:nvSpPr>
-        <p:spPr>
-          <a:xfrm>
-            <a:off x="685800" y="6250000"/>
-            <a:ext cx="9400000" cy="420000"/>
+              <a:rPr lang="en-US" sz="2900" b="1">
+                <a:solidFill>
+                  <a:srgbClr val="071923"/>
+                </a:solidFill>
+                <a:latin typeface="+mj-lt"/>
+              </a:rPr>
+              <a:t>2.</a:t>
+            </a:r>
+            <a:r>
+              <a:rPr lang="en-US" sz="2900" b="1">
+                <a:solidFill>
+                  <a:srgbClr val="006EC3"/>
+                </a:solidFill>
+                <a:latin typeface="+mj-lt"/>
+              </a:rPr>
+              <a:t> Govern access</a:t>
+            </a:r>
+          </a:p>
+        </p:txBody>
+      </p:sp>
+      <p:sp>
+        <p:nvSpPr>
+          <p:cNvPr id="7" name="Body"/>
+          <p:cNvSpPr txBox="1"/>
+          <p:nvPr/>
+        </p:nvSpPr>
+        <p:spPr>
+          <a:xfrm>
+            <a:off x="685800" y="1950000"/>
+            <a:ext cx="3900000" cy="3900000"/>
           </a:xfrm>
           <a:prstGeom prst="rect">
             <a:avLst/>
@@ -1861,26 +2017,77 @@
               </a:spcAft>
             </a:pPr>
             <a:r>
-              <a:rPr lang="en-US" sz="1000">
-                <a:solidFill>
-                  <a:srgbClr val="B4B7B5"/>
-                </a:solidFill>
-              </a:rPr>
-              <a:t>Sources: What is Microsoft Copilot?  ·  Overview of Microsoft Copilot Chat  ·  GitHub Copilot · Your AI coding agent · GitHub  ·  +1 more</a:t>
-            </a:r>
-          </a:p>
-        </p:txBody>
-      </p:sp>
-      <p:sp>
-        <p:nvSpPr>
-          <p:cNvPr id="8" name="Slide number"/>
-          <p:cNvSpPr txBox="1"/>
-          <p:nvPr/>
-        </p:nvSpPr>
-        <p:spPr>
-          <a:xfrm>
-            <a:off x="10100000" y="6250000"/>
-            <a:ext cx="1400000" cy="420000"/>
+              <a:rPr lang="en-US" sz="2500">
+                <a:solidFill>
+                  <a:srgbClr val="071923"/>
+                </a:solidFill>
+              </a:rPr>
+              <a:t>Microsoft 365 Copilot brings AI into work apps. Grounding, user permissions, compliance controls and license level shape what it can answer for each person.</a:t>
+            </a:r>
+          </a:p>
+        </p:txBody>
+      </p:sp>
+      <p:sp>
+        <p:nvSpPr>
+          <p:cNvPr id="8" name="Accent rule"/>
+          <p:cNvSpPr/>
+          <p:nvPr/>
+        </p:nvSpPr>
+        <p:spPr>
+          <a:xfrm>
+            <a:off x="548640" y="2000000"/>
+            <a:ext cx="45720" cy="3800000"/>
+          </a:xfrm>
+          <a:prstGeom prst="rect">
+            <a:avLst/>
+          </a:prstGeom>
+          <a:solidFill>
+            <a:srgbClr val="006EC3"/>
+          </a:solidFill>
+          <a:ln>
+            <a:noFill/>
+          </a:ln>
+        </p:spPr>
+      </p:sp>
+      <p:pic>
+        <p:nvPicPr>
+          <p:cNvPr id="9" name="Asset visual-govern-access" descr="Access governance makes the permitted information boundary explicit. (excalidraw diagram)"/>
+          <p:cNvPicPr>
+            <a:picLocks noChangeAspect="1"/>
+          </p:cNvPicPr>
+          <p:nvPr/>
+        </p:nvPicPr>
+        <p:blipFill>
+          <a:blip r:embed="rIdImage1"/>
+          <a:stretch>
+            <a:fillRect/>
+          </a:stretch>
+        </p:blipFill>
+        <p:spPr>
+          <a:xfrm>
+            <a:off x="5000000" y="2221875"/>
+            <a:ext cx="6500000" cy="3656250"/>
+          </a:xfrm>
+          <a:prstGeom prst="rect">
+            <a:avLst/>
+          </a:prstGeom>
+          <a:ln>
+            <a:solidFill>
+              <a:srgbClr val="D9D9D9"/>
+            </a:solidFill>
+          </a:ln>
+        </p:spPr>
+      </p:pic>
+      <p:sp>
+        <p:nvSpPr>
+          <p:cNvPr id="10" name="Footer"/>
+          <p:cNvSpPr txBox="1"/>
+          <p:nvPr/>
+        </p:nvSpPr>
+        <p:spPr>
+          <a:xfrm>
+            <a:off x="685800" y="6250000"/>
+            <a:ext cx="10820400" cy="420000"/>
           </a:xfrm>
           <a:prstGeom prst="rect">
             <a:avLst/>
@@ -1896,14 +2103,21 @@
           </a:bodyPr>
           <a:lstStyle/>
           <a:p>
-            <a:pPr algn="r"/>
+            <a:pPr algn="l">
+              <a:lnSpc>
+                <a:spcPct val="105000"/>
+              </a:lnSpc>
+              <a:spcAft>
+                <a:spcPts val="0"/>
+              </a:spcAft>
+            </a:pPr>
             <a:r>
               <a:rPr lang="en-US" sz="1000">
                 <a:solidFill>
-                  <a:srgbClr val="B4B7B5"/>
-                </a:solidFill>
-              </a:rPr>
-              <a:t>3 / 6</a:t>
+                  <a:srgbClr val="626C71"/>
+                </a:solidFill>
+              </a:rPr>
+              <a:t>Sources: What is Microsoft Copilot?  ·  Overview of Microsoft Copilot Chat  ·  GitHub Copilot · Your AI coding agent · GitHub  ·  +1 more</a:t>
             </a:r>
           </a:p>
         </p:txBody>
@@ -1922,7 +2136,7 @@
     <p:bg>
       <p:bgPr>
         <a:solidFill>
-          <a:srgbClr val="101312"/>
+          <a:srgbClr val="F4F8FC"/>
         </a:solidFill>
         <a:effectLst/>
       </p:bgPr>
@@ -1936,20 +2150,20 @@
       <p:grpSpPr/>
       <p:sp>
         <p:nvSpPr>
-          <p:cNvPr id="2" name="Accent band"/>
+          <p:cNvPr id="2" name="Brand band"/>
           <p:cNvSpPr/>
           <p:nvPr/>
         </p:nvSpPr>
         <p:spPr>
           <a:xfrm>
             <a:off x="0" y="0"/>
-            <a:ext cx="12192000" cy="91440"/>
+            <a:ext cx="12192000" cy="502920"/>
           </a:xfrm>
           <a:prstGeom prst="rect">
             <a:avLst/>
           </a:prstGeom>
           <a:solidFill>
-            <a:srgbClr val="55C2B8"/>
+            <a:srgbClr val="091F2C"/>
           </a:solidFill>
           <a:ln>
             <a:noFill/>
@@ -1958,14 +2172,36 @@
       </p:sp>
       <p:sp>
         <p:nvSpPr>
-          <p:cNvPr id="3" name="Title"/>
-          <p:cNvSpPr txBox="1"/>
-          <p:nvPr/>
-        </p:nvSpPr>
-        <p:spPr>
-          <a:xfrm>
-            <a:off x="685800" y="420000"/>
-            <a:ext cx="10820400" cy="1150000"/>
+          <p:cNvPr id="3" name="Highlight rule"/>
+          <p:cNvSpPr/>
+          <p:nvPr/>
+        </p:nvSpPr>
+        <p:spPr>
+          <a:xfrm>
+            <a:off x="0" y="502920"/>
+            <a:ext cx="12192000" cy="45720"/>
+          </a:xfrm>
+          <a:prstGeom prst="rect">
+            <a:avLst/>
+          </a:prstGeom>
+          <a:solidFill>
+            <a:srgbClr val="50E6FF"/>
+          </a:solidFill>
+          <a:ln>
+            <a:noFill/>
+          </a:ln>
+        </p:spPr>
+      </p:sp>
+      <p:sp>
+        <p:nvSpPr>
+          <p:cNvPr id="4" name="Deck kicker"/>
+          <p:cNvSpPr txBox="1"/>
+          <p:nvPr/>
+        </p:nvSpPr>
+        <p:spPr>
+          <a:xfrm>
+            <a:off x="685800" y="0"/>
+            <a:ext cx="8400000" cy="502920"/>
           </a:xfrm>
           <a:prstGeom prst="rect">
             <a:avLst/>
@@ -1990,45 +2226,74 @@
               </a:spcAft>
             </a:pPr>
             <a:r>
-              <a:rPr lang="en-US" sz="2900" b="1">
-                <a:solidFill>
-                  <a:srgbClr val="F4F7F5"/>
-                </a:solidFill>
-              </a:rPr>
-              <a:t>3.</a:t>
-            </a:r>
-            <a:r>
-              <a:rPr lang="en-US" sz="2900" b="1">
-                <a:solidFill>
-                  <a:srgbClr val="55C2B8"/>
-                </a:solidFill>
-              </a:rPr>
-              <a:t> Separate builders</a:t>
-            </a:r>
-          </a:p>
-        </p:txBody>
-      </p:sp>
-      <p:sp>
-        <p:nvSpPr>
-          <p:cNvPr id="4" name="Body"/>
-          <p:cNvSpPr txBox="1"/>
-          <p:nvPr/>
-        </p:nvSpPr>
-        <p:spPr>
-          <a:xfrm>
-            <a:off x="685800" y="1750000"/>
-            <a:ext cx="3900000" cy="3900000"/>
-          </a:xfrm>
-          <a:prstGeom prst="rect">
-            <a:avLst/>
-          </a:prstGeom>
-          <a:noFill/>
-          <a:ln>
-            <a:noFill/>
-          </a:ln>
-        </p:spPr>
-        <p:txBody>
-          <a:bodyPr wrap="square" lIns="182880" tIns="91440" rIns="182880" bIns="91440" anchor="t">
+              <a:rPr lang="en-US" sz="1100" b="1" cap="all" spc="120">
+                <a:solidFill>
+                  <a:srgbClr val="FFFFFF"/>
+                </a:solidFill>
+              </a:rPr>
+              <a:t>Copilot</a:t>
+            </a:r>
+          </a:p>
+        </p:txBody>
+      </p:sp>
+      <p:sp>
+        <p:nvSpPr>
+          <p:cNvPr id="5" name="Slide number"/>
+          <p:cNvSpPr txBox="1"/>
+          <p:nvPr/>
+        </p:nvSpPr>
+        <p:spPr>
+          <a:xfrm>
+            <a:off x="9100000" y="0"/>
+            <a:ext cx="2406400" cy="502920"/>
+          </a:xfrm>
+          <a:prstGeom prst="rect">
+            <a:avLst/>
+          </a:prstGeom>
+          <a:noFill/>
+          <a:ln>
+            <a:noFill/>
+          </a:ln>
+        </p:spPr>
+        <p:txBody>
+          <a:bodyPr wrap="square" lIns="182880" tIns="91440" rIns="182880" bIns="91440" anchor="ctr">
+            <a:normAutofit/>
+          </a:bodyPr>
+          <a:lstStyle/>
+          <a:p>
+            <a:pPr algn="r"/>
+            <a:r>
+              <a:rPr lang="en-US" sz="1100" b="1" cap="all" spc="120">
+                <a:solidFill>
+                  <a:srgbClr val="BAC0C4"/>
+                </a:solidFill>
+              </a:rPr>
+              <a:t>4 / 6</a:t>
+            </a:r>
+          </a:p>
+        </p:txBody>
+      </p:sp>
+      <p:sp>
+        <p:nvSpPr>
+          <p:cNvPr id="6" name="Title"/>
+          <p:cNvSpPr txBox="1"/>
+          <p:nvPr/>
+        </p:nvSpPr>
+        <p:spPr>
+          <a:xfrm>
+            <a:off x="685800" y="700000"/>
+            <a:ext cx="10820400" cy="1150000"/>
+          </a:xfrm>
+          <a:prstGeom prst="rect">
+            <a:avLst/>
+          </a:prstGeom>
+          <a:noFill/>
+          <a:ln>
+            <a:noFill/>
+          </a:ln>
+        </p:spPr>
+        <p:txBody>
+          <a:bodyPr wrap="square" lIns="182880" tIns="91440" rIns="182880" bIns="91440" anchor="ctr">
             <a:normAutofit/>
           </a:bodyPr>
           <a:lstStyle/>
@@ -2042,77 +2307,36 @@
               </a:spcAft>
             </a:pPr>
             <a:r>
-              <a:rPr lang="en-US" sz="2400">
-                <a:solidFill>
-                  <a:srgbClr val="F4F7F5"/>
-                </a:solidFill>
-              </a:rPr>
-              <a:t>GitHub Copilot fits coding workflows in developer tools. Copilot Studio builds agents and workflows connected to organizational data, systems, and channels for teams.</a:t>
-            </a:r>
-          </a:p>
-        </p:txBody>
-      </p:sp>
-      <p:sp>
-        <p:nvSpPr>
-          <p:cNvPr id="5" name="Accent rule"/>
-          <p:cNvSpPr/>
-          <p:nvPr/>
-        </p:nvSpPr>
-        <p:spPr>
-          <a:xfrm>
-            <a:off x="548640" y="1800000"/>
-            <a:ext cx="45720" cy="3800000"/>
-          </a:xfrm>
-          <a:prstGeom prst="rect">
-            <a:avLst/>
-          </a:prstGeom>
-          <a:solidFill>
-            <a:srgbClr val="55C2B8"/>
-          </a:solidFill>
-          <a:ln>
-            <a:noFill/>
-          </a:ln>
-        </p:spPr>
-      </p:sp>
-      <p:pic>
-        <p:nvPicPr>
-          <p:cNvPr id="6" name="Asset visual-builder-routes" descr="Coding assistance and business-agent building are different routes. (marp diagram)"/>
-          <p:cNvPicPr>
-            <a:picLocks noChangeAspect="1"/>
-          </p:cNvPicPr>
-          <p:nvPr/>
-        </p:nvPicPr>
-        <p:blipFill>
-          <a:blip r:embed="rIdImage1"/>
-          <a:stretch>
-            <a:fillRect/>
-          </a:stretch>
-        </p:blipFill>
-        <p:spPr>
-          <a:xfrm>
-            <a:off x="5000000" y="2021875"/>
-            <a:ext cx="6500000" cy="3656250"/>
-          </a:xfrm>
-          <a:prstGeom prst="rect">
-            <a:avLst/>
-          </a:prstGeom>
-          <a:ln>
-            <a:solidFill>
-              <a:srgbClr val="D9D9D9"/>
-            </a:solidFill>
-          </a:ln>
-        </p:spPr>
-      </p:pic>
-      <p:sp>
-        <p:nvSpPr>
-          <p:cNvPr id="7" name="Footer"/>
-          <p:cNvSpPr txBox="1"/>
-          <p:nvPr/>
-        </p:nvSpPr>
-        <p:spPr>
-          <a:xfrm>
-            <a:off x="685800" y="6250000"/>
-            <a:ext cx="9400000" cy="420000"/>
+              <a:rPr lang="en-US" sz="2900" b="1">
+                <a:solidFill>
+                  <a:srgbClr val="071923"/>
+                </a:solidFill>
+                <a:latin typeface="+mj-lt"/>
+              </a:rPr>
+              <a:t>3.</a:t>
+            </a:r>
+            <a:r>
+              <a:rPr lang="en-US" sz="2900" b="1">
+                <a:solidFill>
+                  <a:srgbClr val="006EC3"/>
+                </a:solidFill>
+                <a:latin typeface="+mj-lt"/>
+              </a:rPr>
+              <a:t> Separate builders</a:t>
+            </a:r>
+          </a:p>
+        </p:txBody>
+      </p:sp>
+      <p:sp>
+        <p:nvSpPr>
+          <p:cNvPr id="7" name="Body"/>
+          <p:cNvSpPr txBox="1"/>
+          <p:nvPr/>
+        </p:nvSpPr>
+        <p:spPr>
+          <a:xfrm>
+            <a:off x="685800" y="1950000"/>
+            <a:ext cx="3900000" cy="3900000"/>
           </a:xfrm>
           <a:prstGeom prst="rect">
             <a:avLst/>
@@ -2137,26 +2361,77 @@
               </a:spcAft>
             </a:pPr>
             <a:r>
-              <a:rPr lang="en-US" sz="1000">
-                <a:solidFill>
-                  <a:srgbClr val="B4B7B5"/>
-                </a:solidFill>
-              </a:rPr>
-              <a:t>Sources: GitHub Copilot · Your AI coding agent · GitHub  ·  Overview - Microsoft Copilot Studio</a:t>
-            </a:r>
-          </a:p>
-        </p:txBody>
-      </p:sp>
-      <p:sp>
-        <p:nvSpPr>
-          <p:cNvPr id="8" name="Slide number"/>
-          <p:cNvSpPr txBox="1"/>
-          <p:nvPr/>
-        </p:nvSpPr>
-        <p:spPr>
-          <a:xfrm>
-            <a:off x="10100000" y="6250000"/>
-            <a:ext cx="1400000" cy="420000"/>
+              <a:rPr lang="en-US" sz="2400">
+                <a:solidFill>
+                  <a:srgbClr val="071923"/>
+                </a:solidFill>
+              </a:rPr>
+              <a:t>GitHub Copilot fits coding workflows in developer tools. Copilot Studio builds agents and workflows connected to organizational data, systems, and channels for teams.</a:t>
+            </a:r>
+          </a:p>
+        </p:txBody>
+      </p:sp>
+      <p:sp>
+        <p:nvSpPr>
+          <p:cNvPr id="8" name="Accent rule"/>
+          <p:cNvSpPr/>
+          <p:nvPr/>
+        </p:nvSpPr>
+        <p:spPr>
+          <a:xfrm>
+            <a:off x="548640" y="2000000"/>
+            <a:ext cx="45720" cy="3800000"/>
+          </a:xfrm>
+          <a:prstGeom prst="rect">
+            <a:avLst/>
+          </a:prstGeom>
+          <a:solidFill>
+            <a:srgbClr val="006EC3"/>
+          </a:solidFill>
+          <a:ln>
+            <a:noFill/>
+          </a:ln>
+        </p:spPr>
+      </p:sp>
+      <p:pic>
+        <p:nvPicPr>
+          <p:cNvPr id="9" name="Asset visual-builder-routes" descr="Coding assistance and business-agent building are different routes. (marp diagram)"/>
+          <p:cNvPicPr>
+            <a:picLocks noChangeAspect="1"/>
+          </p:cNvPicPr>
+          <p:nvPr/>
+        </p:nvPicPr>
+        <p:blipFill>
+          <a:blip r:embed="rIdImage1"/>
+          <a:stretch>
+            <a:fillRect/>
+          </a:stretch>
+        </p:blipFill>
+        <p:spPr>
+          <a:xfrm>
+            <a:off x="5000000" y="2221875"/>
+            <a:ext cx="6500000" cy="3656250"/>
+          </a:xfrm>
+          <a:prstGeom prst="rect">
+            <a:avLst/>
+          </a:prstGeom>
+          <a:ln>
+            <a:solidFill>
+              <a:srgbClr val="D9D9D9"/>
+            </a:solidFill>
+          </a:ln>
+        </p:spPr>
+      </p:pic>
+      <p:sp>
+        <p:nvSpPr>
+          <p:cNvPr id="10" name="Footer"/>
+          <p:cNvSpPr txBox="1"/>
+          <p:nvPr/>
+        </p:nvSpPr>
+        <p:spPr>
+          <a:xfrm>
+            <a:off x="685800" y="6250000"/>
+            <a:ext cx="10820400" cy="420000"/>
           </a:xfrm>
           <a:prstGeom prst="rect">
             <a:avLst/>
@@ -2172,14 +2447,21 @@
           </a:bodyPr>
           <a:lstStyle/>
           <a:p>
-            <a:pPr algn="r"/>
+            <a:pPr algn="l">
+              <a:lnSpc>
+                <a:spcPct val="105000"/>
+              </a:lnSpc>
+              <a:spcAft>
+                <a:spcPts val="0"/>
+              </a:spcAft>
+            </a:pPr>
             <a:r>
               <a:rPr lang="en-US" sz="1000">
                 <a:solidFill>
-                  <a:srgbClr val="B4B7B5"/>
-                </a:solidFill>
-              </a:rPr>
-              <a:t>4 / 6</a:t>
+                  <a:srgbClr val="626C71"/>
+                </a:solidFill>
+              </a:rPr>
+              <a:t>Sources: GitHub Copilot · Your AI coding agent · GitHub  ·  Overview - Microsoft Copilot Studio</a:t>
             </a:r>
           </a:p>
         </p:txBody>
@@ -2198,7 +2480,7 @@
     <p:bg>
       <p:bgPr>
         <a:solidFill>
-          <a:srgbClr val="101312"/>
+          <a:srgbClr val="F4F8FC"/>
         </a:solidFill>
         <a:effectLst/>
       </p:bgPr>
@@ -2212,20 +2494,20 @@
       <p:grpSpPr/>
       <p:sp>
         <p:nvSpPr>
-          <p:cNvPr id="2" name="Accent band"/>
+          <p:cNvPr id="2" name="Brand band"/>
           <p:cNvSpPr/>
           <p:nvPr/>
         </p:nvSpPr>
         <p:spPr>
           <a:xfrm>
             <a:off x="0" y="0"/>
-            <a:ext cx="12192000" cy="91440"/>
+            <a:ext cx="12192000" cy="502920"/>
           </a:xfrm>
           <a:prstGeom prst="rect">
             <a:avLst/>
           </a:prstGeom>
           <a:solidFill>
-            <a:srgbClr val="55C2B8"/>
+            <a:srgbClr val="091F2C"/>
           </a:solidFill>
           <a:ln>
             <a:noFill/>
@@ -2234,14 +2516,36 @@
       </p:sp>
       <p:sp>
         <p:nvSpPr>
-          <p:cNvPr id="3" name="Title"/>
-          <p:cNvSpPr txBox="1"/>
-          <p:nvPr/>
-        </p:nvSpPr>
-        <p:spPr>
-          <a:xfrm>
-            <a:off x="685800" y="420000"/>
-            <a:ext cx="10820400" cy="1150000"/>
+          <p:cNvPr id="3" name="Highlight rule"/>
+          <p:cNvSpPr/>
+          <p:nvPr/>
+        </p:nvSpPr>
+        <p:spPr>
+          <a:xfrm>
+            <a:off x="0" y="502920"/>
+            <a:ext cx="12192000" cy="45720"/>
+          </a:xfrm>
+          <a:prstGeom prst="rect">
+            <a:avLst/>
+          </a:prstGeom>
+          <a:solidFill>
+            <a:srgbClr val="50E6FF"/>
+          </a:solidFill>
+          <a:ln>
+            <a:noFill/>
+          </a:ln>
+        </p:spPr>
+      </p:sp>
+      <p:sp>
+        <p:nvSpPr>
+          <p:cNvPr id="4" name="Deck kicker"/>
+          <p:cNvSpPr txBox="1"/>
+          <p:nvPr/>
+        </p:nvSpPr>
+        <p:spPr>
+          <a:xfrm>
+            <a:off x="685800" y="0"/>
+            <a:ext cx="8400000" cy="502920"/>
           </a:xfrm>
           <a:prstGeom prst="rect">
             <a:avLst/>
@@ -2266,45 +2570,74 @@
               </a:spcAft>
             </a:pPr>
             <a:r>
-              <a:rPr lang="en-US" sz="2900" b="1">
-                <a:solidFill>
-                  <a:srgbClr val="F4F7F5"/>
-                </a:solidFill>
-              </a:rPr>
-              <a:t>4.</a:t>
-            </a:r>
-            <a:r>
-              <a:rPr lang="en-US" sz="2900" b="1">
-                <a:solidFill>
-                  <a:srgbClr val="55C2B8"/>
-                </a:solidFill>
-              </a:rPr>
-              <a:t> Run decision checks</a:t>
-            </a:r>
-          </a:p>
-        </p:txBody>
-      </p:sp>
-      <p:sp>
-        <p:nvSpPr>
-          <p:cNvPr id="4" name="Body"/>
-          <p:cNvSpPr txBox="1"/>
-          <p:nvPr/>
-        </p:nvSpPr>
-        <p:spPr>
-          <a:xfrm>
-            <a:off x="685800" y="1750000"/>
-            <a:ext cx="3900000" cy="3900000"/>
-          </a:xfrm>
-          <a:prstGeom prst="rect">
-            <a:avLst/>
-          </a:prstGeom>
-          <a:noFill/>
-          <a:ln>
-            <a:noFill/>
-          </a:ln>
-        </p:spPr>
-        <p:txBody>
-          <a:bodyPr wrap="square" lIns="182880" tIns="91440" rIns="182880" bIns="91440" anchor="t">
+              <a:rPr lang="en-US" sz="1100" b="1" cap="all" spc="120">
+                <a:solidFill>
+                  <a:srgbClr val="FFFFFF"/>
+                </a:solidFill>
+              </a:rPr>
+              <a:t>Copilot</a:t>
+            </a:r>
+          </a:p>
+        </p:txBody>
+      </p:sp>
+      <p:sp>
+        <p:nvSpPr>
+          <p:cNvPr id="5" name="Slide number"/>
+          <p:cNvSpPr txBox="1"/>
+          <p:nvPr/>
+        </p:nvSpPr>
+        <p:spPr>
+          <a:xfrm>
+            <a:off x="9100000" y="0"/>
+            <a:ext cx="2406400" cy="502920"/>
+          </a:xfrm>
+          <a:prstGeom prst="rect">
+            <a:avLst/>
+          </a:prstGeom>
+          <a:noFill/>
+          <a:ln>
+            <a:noFill/>
+          </a:ln>
+        </p:spPr>
+        <p:txBody>
+          <a:bodyPr wrap="square" lIns="182880" tIns="91440" rIns="182880" bIns="91440" anchor="ctr">
+            <a:normAutofit/>
+          </a:bodyPr>
+          <a:lstStyle/>
+          <a:p>
+            <a:pPr algn="r"/>
+            <a:r>
+              <a:rPr lang="en-US" sz="1100" b="1" cap="all" spc="120">
+                <a:solidFill>
+                  <a:srgbClr val="BAC0C4"/>
+                </a:solidFill>
+              </a:rPr>
+              <a:t>5 / 6</a:t>
+            </a:r>
+          </a:p>
+        </p:txBody>
+      </p:sp>
+      <p:sp>
+        <p:nvSpPr>
+          <p:cNvPr id="6" name="Title"/>
+          <p:cNvSpPr txBox="1"/>
+          <p:nvPr/>
+        </p:nvSpPr>
+        <p:spPr>
+          <a:xfrm>
+            <a:off x="685800" y="700000"/>
+            <a:ext cx="10820400" cy="1150000"/>
+          </a:xfrm>
+          <a:prstGeom prst="rect">
+            <a:avLst/>
+          </a:prstGeom>
+          <a:noFill/>
+          <a:ln>
+            <a:noFill/>
+          </a:ln>
+        </p:spPr>
+        <p:txBody>
+          <a:bodyPr wrap="square" lIns="182880" tIns="91440" rIns="182880" bIns="91440" anchor="ctr">
             <a:normAutofit/>
           </a:bodyPr>
           <a:lstStyle/>
@@ -2318,77 +2651,36 @@
               </a:spcAft>
             </a:pPr>
             <a:r>
-              <a:rPr lang="en-US" sz="2500">
-                <a:solidFill>
-                  <a:srgbClr val="F4F7F5"/>
-                </a:solidFill>
-              </a:rPr>
-              <a:t>Make the decision after the fit is clear. Check permissions, license tier, and grounding so leaders know what each output can and cannot use in practice.</a:t>
-            </a:r>
-          </a:p>
-        </p:txBody>
-      </p:sp>
-      <p:sp>
-        <p:nvSpPr>
-          <p:cNvPr id="5" name="Accent rule"/>
-          <p:cNvSpPr/>
-          <p:nvPr/>
-        </p:nvSpPr>
-        <p:spPr>
-          <a:xfrm>
-            <a:off x="548640" y="1800000"/>
-            <a:ext cx="45720" cy="3800000"/>
-          </a:xfrm>
-          <a:prstGeom prst="rect">
-            <a:avLst/>
-          </a:prstGeom>
-          <a:solidFill>
-            <a:srgbClr val="55C2B8"/>
-          </a:solidFill>
-          <a:ln>
-            <a:noFill/>
-          </a:ln>
-        </p:spPr>
-      </p:sp>
-      <p:pic>
-        <p:nvPicPr>
-          <p:cNvPr id="6" name="Asset visual-decision-checks" descr="The final executive gate checks fit, access, licensing and grounding. (marp diagram)"/>
-          <p:cNvPicPr>
-            <a:picLocks noChangeAspect="1"/>
-          </p:cNvPicPr>
-          <p:nvPr/>
-        </p:nvPicPr>
-        <p:blipFill>
-          <a:blip r:embed="rIdImage1"/>
-          <a:stretch>
-            <a:fillRect/>
-          </a:stretch>
-        </p:blipFill>
-        <p:spPr>
-          <a:xfrm>
-            <a:off x="5000000" y="2021875"/>
-            <a:ext cx="6500000" cy="3656250"/>
-          </a:xfrm>
-          <a:prstGeom prst="rect">
-            <a:avLst/>
-          </a:prstGeom>
-          <a:ln>
-            <a:solidFill>
-              <a:srgbClr val="D9D9D9"/>
-            </a:solidFill>
-          </a:ln>
-        </p:spPr>
-      </p:pic>
-      <p:sp>
-        <p:nvSpPr>
-          <p:cNvPr id="7" name="Footer"/>
-          <p:cNvSpPr txBox="1"/>
-          <p:nvPr/>
-        </p:nvSpPr>
-        <p:spPr>
-          <a:xfrm>
-            <a:off x="685800" y="6250000"/>
-            <a:ext cx="9400000" cy="420000"/>
+              <a:rPr lang="en-US" sz="2900" b="1">
+                <a:solidFill>
+                  <a:srgbClr val="071923"/>
+                </a:solidFill>
+                <a:latin typeface="+mj-lt"/>
+              </a:rPr>
+              <a:t>4.</a:t>
+            </a:r>
+            <a:r>
+              <a:rPr lang="en-US" sz="2900" b="1">
+                <a:solidFill>
+                  <a:srgbClr val="006EC3"/>
+                </a:solidFill>
+                <a:latin typeface="+mj-lt"/>
+              </a:rPr>
+              <a:t> Run decision checks</a:t>
+            </a:r>
+          </a:p>
+        </p:txBody>
+      </p:sp>
+      <p:sp>
+        <p:nvSpPr>
+          <p:cNvPr id="7" name="Body"/>
+          <p:cNvSpPr txBox="1"/>
+          <p:nvPr/>
+        </p:nvSpPr>
+        <p:spPr>
+          <a:xfrm>
+            <a:off x="685800" y="1950000"/>
+            <a:ext cx="3900000" cy="3900000"/>
           </a:xfrm>
           <a:prstGeom prst="rect">
             <a:avLst/>
@@ -2413,26 +2705,77 @@
               </a:spcAft>
             </a:pPr>
             <a:r>
-              <a:rPr lang="en-US" sz="1000">
-                <a:solidFill>
-                  <a:srgbClr val="B4B7B5"/>
-                </a:solidFill>
-              </a:rPr>
-              <a:t>Sources: What is Microsoft Copilot?  ·  Overview of Microsoft Copilot Chat  ·  GitHub Copilot · Your AI coding agent · GitHub  ·  +1 more</a:t>
-            </a:r>
-          </a:p>
-        </p:txBody>
-      </p:sp>
-      <p:sp>
-        <p:nvSpPr>
-          <p:cNvPr id="8" name="Slide number"/>
-          <p:cNvSpPr txBox="1"/>
-          <p:nvPr/>
-        </p:nvSpPr>
-        <p:spPr>
-          <a:xfrm>
-            <a:off x="10100000" y="6250000"/>
-            <a:ext cx="1400000" cy="420000"/>
+              <a:rPr lang="en-US" sz="2500">
+                <a:solidFill>
+                  <a:srgbClr val="071923"/>
+                </a:solidFill>
+              </a:rPr>
+              <a:t>Make the decision after the fit is clear. Check permissions, license tier, and grounding so leaders know what each output can and cannot use in practice.</a:t>
+            </a:r>
+          </a:p>
+        </p:txBody>
+      </p:sp>
+      <p:sp>
+        <p:nvSpPr>
+          <p:cNvPr id="8" name="Accent rule"/>
+          <p:cNvSpPr/>
+          <p:nvPr/>
+        </p:nvSpPr>
+        <p:spPr>
+          <a:xfrm>
+            <a:off x="548640" y="2000000"/>
+            <a:ext cx="45720" cy="3800000"/>
+          </a:xfrm>
+          <a:prstGeom prst="rect">
+            <a:avLst/>
+          </a:prstGeom>
+          <a:solidFill>
+            <a:srgbClr val="006EC3"/>
+          </a:solidFill>
+          <a:ln>
+            <a:noFill/>
+          </a:ln>
+        </p:spPr>
+      </p:sp>
+      <p:pic>
+        <p:nvPicPr>
+          <p:cNvPr id="9" name="Asset visual-decision-checks" descr="The final executive gate checks fit, access, licensing and grounding. (marp diagram)"/>
+          <p:cNvPicPr>
+            <a:picLocks noChangeAspect="1"/>
+          </p:cNvPicPr>
+          <p:nvPr/>
+        </p:nvPicPr>
+        <p:blipFill>
+          <a:blip r:embed="rIdImage1"/>
+          <a:stretch>
+            <a:fillRect/>
+          </a:stretch>
+        </p:blipFill>
+        <p:spPr>
+          <a:xfrm>
+            <a:off x="5000000" y="2221875"/>
+            <a:ext cx="6500000" cy="3656250"/>
+          </a:xfrm>
+          <a:prstGeom prst="rect">
+            <a:avLst/>
+          </a:prstGeom>
+          <a:ln>
+            <a:solidFill>
+              <a:srgbClr val="D9D9D9"/>
+            </a:solidFill>
+          </a:ln>
+        </p:spPr>
+      </p:pic>
+      <p:sp>
+        <p:nvSpPr>
+          <p:cNvPr id="10" name="Footer"/>
+          <p:cNvSpPr txBox="1"/>
+          <p:nvPr/>
+        </p:nvSpPr>
+        <p:spPr>
+          <a:xfrm>
+            <a:off x="685800" y="6250000"/>
+            <a:ext cx="10820400" cy="420000"/>
           </a:xfrm>
           <a:prstGeom prst="rect">
             <a:avLst/>
@@ -2448,14 +2791,21 @@
           </a:bodyPr>
           <a:lstStyle/>
           <a:p>
-            <a:pPr algn="r"/>
+            <a:pPr algn="l">
+              <a:lnSpc>
+                <a:spcPct val="105000"/>
+              </a:lnSpc>
+              <a:spcAft>
+                <a:spcPts val="0"/>
+              </a:spcAft>
+            </a:pPr>
             <a:r>
               <a:rPr lang="en-US" sz="1000">
                 <a:solidFill>
-                  <a:srgbClr val="B4B7B5"/>
-                </a:solidFill>
-              </a:rPr>
-              <a:t>5 / 6</a:t>
+                  <a:srgbClr val="626C71"/>
+                </a:solidFill>
+              </a:rPr>
+              <a:t>Sources: What is Microsoft Copilot?  ·  Overview of Microsoft Copilot Chat  ·  GitHub Copilot · Your AI coding agent · GitHub  ·  +1 more</a:t>
             </a:r>
           </a:p>
         </p:txBody>
@@ -2474,7 +2824,7 @@
     <p:bg>
       <p:bgPr>
         <a:solidFill>
-          <a:srgbClr val="101312"/>
+          <a:srgbClr val="F4F8FC"/>
         </a:solidFill>
         <a:effectLst/>
       </p:bgPr>
@@ -2488,20 +2838,20 @@
       <p:grpSpPr/>
       <p:sp>
         <p:nvSpPr>
-          <p:cNvPr id="2" name="Accent band"/>
+          <p:cNvPr id="2" name="Brand band"/>
           <p:cNvSpPr/>
           <p:nvPr/>
         </p:nvSpPr>
         <p:spPr>
           <a:xfrm>
             <a:off x="0" y="0"/>
-            <a:ext cx="12192000" cy="91440"/>
+            <a:ext cx="12192000" cy="502920"/>
           </a:xfrm>
           <a:prstGeom prst="rect">
             <a:avLst/>
           </a:prstGeom>
           <a:solidFill>
-            <a:srgbClr val="55C2B8"/>
+            <a:srgbClr val="091F2C"/>
           </a:solidFill>
           <a:ln>
             <a:noFill/>
@@ -2510,14 +2860,36 @@
       </p:sp>
       <p:sp>
         <p:nvSpPr>
-          <p:cNvPr id="3" name="Title"/>
-          <p:cNvSpPr txBox="1"/>
-          <p:nvPr/>
-        </p:nvSpPr>
-        <p:spPr>
-          <a:xfrm>
-            <a:off x="685800" y="420000"/>
-            <a:ext cx="10820400" cy="1000000"/>
+          <p:cNvPr id="3" name="Highlight rule"/>
+          <p:cNvSpPr/>
+          <p:nvPr/>
+        </p:nvSpPr>
+        <p:spPr>
+          <a:xfrm>
+            <a:off x="0" y="502920"/>
+            <a:ext cx="12192000" cy="45720"/>
+          </a:xfrm>
+          <a:prstGeom prst="rect">
+            <a:avLst/>
+          </a:prstGeom>
+          <a:solidFill>
+            <a:srgbClr val="50E6FF"/>
+          </a:solidFill>
+          <a:ln>
+            <a:noFill/>
+          </a:ln>
+        </p:spPr>
+      </p:sp>
+      <p:sp>
+        <p:nvSpPr>
+          <p:cNvPr id="4" name="Deck kicker"/>
+          <p:cNvSpPr txBox="1"/>
+          <p:nvPr/>
+        </p:nvSpPr>
+        <p:spPr>
+          <a:xfrm>
+            <a:off x="685800" y="0"/>
+            <a:ext cx="8400000" cy="502920"/>
           </a:xfrm>
           <a:prstGeom prst="rect">
             <a:avLst/>
@@ -2542,45 +2914,74 @@
               </a:spcAft>
             </a:pPr>
             <a:r>
-              <a:rPr lang="en-US" sz="2400" b="1">
-                <a:solidFill>
-                  <a:srgbClr val="F4F7F5"/>
-                </a:solidFill>
-              </a:rPr>
-              <a:t>Sources.</a:t>
-            </a:r>
-            <a:r>
-              <a:rPr lang="en-US" sz="2400" b="1">
-                <a:solidFill>
-                  <a:srgbClr val="55C2B8"/>
-                </a:solidFill>
-              </a:rPr>
-              <a:t> Every claim traces to one.</a:t>
-            </a:r>
-          </a:p>
-        </p:txBody>
-      </p:sp>
-      <p:sp>
-        <p:nvSpPr>
-          <p:cNvPr id="4" name="Sources"/>
-          <p:cNvSpPr txBox="1"/>
-          <p:nvPr/>
-        </p:nvSpPr>
-        <p:spPr>
-          <a:xfrm>
-            <a:off x="685800" y="1700000"/>
-            <a:ext cx="10820400" cy="4300000"/>
-          </a:xfrm>
-          <a:prstGeom prst="rect">
-            <a:avLst/>
-          </a:prstGeom>
-          <a:noFill/>
-          <a:ln>
-            <a:noFill/>
-          </a:ln>
-        </p:spPr>
-        <p:txBody>
-          <a:bodyPr wrap="square" lIns="182880" tIns="91440" rIns="182880" bIns="91440" anchor="t">
+              <a:rPr lang="en-US" sz="1100" b="1" cap="all" spc="120">
+                <a:solidFill>
+                  <a:srgbClr val="FFFFFF"/>
+                </a:solidFill>
+              </a:rPr>
+              <a:t>Copilot</a:t>
+            </a:r>
+          </a:p>
+        </p:txBody>
+      </p:sp>
+      <p:sp>
+        <p:nvSpPr>
+          <p:cNvPr id="5" name="Slide number"/>
+          <p:cNvSpPr txBox="1"/>
+          <p:nvPr/>
+        </p:nvSpPr>
+        <p:spPr>
+          <a:xfrm>
+            <a:off x="9100000" y="0"/>
+            <a:ext cx="2406400" cy="502920"/>
+          </a:xfrm>
+          <a:prstGeom prst="rect">
+            <a:avLst/>
+          </a:prstGeom>
+          <a:noFill/>
+          <a:ln>
+            <a:noFill/>
+          </a:ln>
+        </p:spPr>
+        <p:txBody>
+          <a:bodyPr wrap="square" lIns="182880" tIns="91440" rIns="182880" bIns="91440" anchor="ctr">
+            <a:normAutofit/>
+          </a:bodyPr>
+          <a:lstStyle/>
+          <a:p>
+            <a:pPr algn="r"/>
+            <a:r>
+              <a:rPr lang="en-US" sz="1100" b="1" cap="all" spc="120">
+                <a:solidFill>
+                  <a:srgbClr val="BAC0C4"/>
+                </a:solidFill>
+              </a:rPr>
+              <a:t>6 / 6</a:t>
+            </a:r>
+          </a:p>
+        </p:txBody>
+      </p:sp>
+      <p:sp>
+        <p:nvSpPr>
+          <p:cNvPr id="6" name="Title"/>
+          <p:cNvSpPr txBox="1"/>
+          <p:nvPr/>
+        </p:nvSpPr>
+        <p:spPr>
+          <a:xfrm>
+            <a:off x="685800" y="760000"/>
+            <a:ext cx="10820400" cy="1000000"/>
+          </a:xfrm>
+          <a:prstGeom prst="rect">
+            <a:avLst/>
+          </a:prstGeom>
+          <a:noFill/>
+          <a:ln>
+            <a:noFill/>
+          </a:ln>
+        </p:spPr>
+        <p:txBody>
+          <a:bodyPr wrap="square" lIns="182880" tIns="91440" rIns="182880" bIns="91440" anchor="ctr">
             <a:normAutofit/>
           </a:bodyPr>
           <a:lstStyle/>
@@ -2594,9 +2995,63 @@
               </a:spcAft>
             </a:pPr>
             <a:r>
+              <a:rPr lang="en-US" sz="2400" b="1">
+                <a:solidFill>
+                  <a:srgbClr val="071923"/>
+                </a:solidFill>
+                <a:latin typeface="+mj-lt"/>
+              </a:rPr>
+              <a:t>Sources.</a:t>
+            </a:r>
+            <a:r>
+              <a:rPr lang="en-US" sz="2400" b="1">
+                <a:solidFill>
+                  <a:srgbClr val="006EC3"/>
+                </a:solidFill>
+                <a:latin typeface="+mj-lt"/>
+              </a:rPr>
+              <a:t> Every claim traces to one.</a:t>
+            </a:r>
+          </a:p>
+        </p:txBody>
+      </p:sp>
+      <p:sp>
+        <p:nvSpPr>
+          <p:cNvPr id="7" name="Sources"/>
+          <p:cNvSpPr txBox="1"/>
+          <p:nvPr/>
+        </p:nvSpPr>
+        <p:spPr>
+          <a:xfrm>
+            <a:off x="685800" y="1900000"/>
+            <a:ext cx="10820400" cy="4300000"/>
+          </a:xfrm>
+          <a:prstGeom prst="rect">
+            <a:avLst/>
+          </a:prstGeom>
+          <a:noFill/>
+          <a:ln>
+            <a:noFill/>
+          </a:ln>
+        </p:spPr>
+        <p:txBody>
+          <a:bodyPr wrap="square" lIns="182880" tIns="91440" rIns="182880" bIns="91440" anchor="t">
+            <a:normAutofit/>
+          </a:bodyPr>
+          <a:lstStyle/>
+          <a:p>
+            <a:pPr algn="l">
+              <a:lnSpc>
+                <a:spcPct val="105000"/>
+              </a:lnSpc>
+              <a:spcAft>
+                <a:spcPts val="0"/>
+              </a:spcAft>
+            </a:pPr>
+            <a:r>
               <a:rPr lang="en-US" sz="1400" b="1">
                 <a:solidFill>
-                  <a:srgbClr val="F4F7F5"/>
+                  <a:srgbClr val="071923"/>
                 </a:solidFill>
               </a:rPr>
               <a:t>Overview of Microsoft Copilot Chat</a:t>
@@ -2604,7 +3059,7 @@
             <a:r>
               <a:rPr lang="en-US" sz="1100">
                 <a:solidFill>
-                  <a:srgbClr val="B4B7B5"/>
+                  <a:srgbClr val="626C71"/>
                 </a:solidFill>
               </a:rPr>
               <a:t>  retrieved 2026-10-06</a:t>
@@ -2622,7 +3077,7 @@
             <a:r>
               <a:rPr lang="en-US" sz="1100">
                 <a:solidFill>
-                  <a:srgbClr val="55C2B8"/>
+                  <a:srgbClr val="006EC3"/>
                 </a:solidFill>
               </a:rPr>
               <a:t>https://learn.microsoft.com/en-us/copilot/overview</a:t>
@@ -2640,7 +3095,7 @@
             <a:r>
               <a:rPr lang="en-US" sz="1400" b="1">
                 <a:solidFill>
-                  <a:srgbClr val="F4F7F5"/>
+                  <a:srgbClr val="071923"/>
                 </a:solidFill>
               </a:rPr>
               <a:t>What is Microsoft Copilot?</a:t>
@@ -2648,7 +3103,7 @@
             <a:r>
               <a:rPr lang="en-US" sz="1100">
                 <a:solidFill>
-                  <a:srgbClr val="B4B7B5"/>
+                  <a:srgbClr val="626C71"/>
                 </a:solidFill>
               </a:rPr>
               <a:t>  retrieved 2026-10-06</a:t>
@@ -2666,7 +3121,7 @@
             <a:r>
               <a:rPr lang="en-US" sz="1100">
                 <a:solidFill>
-                  <a:srgbClr val="55C2B8"/>
+                  <a:srgbClr val="006EC3"/>
                 </a:solidFill>
               </a:rPr>
               <a:t>https://learn.microsoft.com/en-us/copilot/microsoft-365/microsoft-365-copilot-overview</a:t>
@@ -2684,7 +3139,7 @@
             <a:r>
               <a:rPr lang="en-US" sz="1400" b="1">
                 <a:solidFill>
-                  <a:srgbClr val="F4F7F5"/>
+                  <a:srgbClr val="071923"/>
                 </a:solidFill>
               </a:rPr>
               <a:t>GitHub Copilot · Your AI coding agent · GitHub</a:t>
@@ -2692,7 +3147,7 @@
             <a:r>
               <a:rPr lang="en-US" sz="1100">
                 <a:solidFill>
-                  <a:srgbClr val="B4B7B5"/>
+                  <a:srgbClr val="626C71"/>
                 </a:solidFill>
               </a:rPr>
               <a:t>  retrieved 2026-10-06</a:t>
@@ -2710,7 +3165,7 @@
             <a:r>
               <a:rPr lang="en-US" sz="1100">
                 <a:solidFill>
-                  <a:srgbClr val="55C2B8"/>
+                  <a:srgbClr val="006EC3"/>
                 </a:solidFill>
               </a:rPr>
               <a:t>https://github.com/features/copilot</a:t>
@@ -2728,7 +3183,7 @@
             <a:r>
               <a:rPr lang="en-US" sz="1400" b="1">
                 <a:solidFill>
-                  <a:srgbClr val="F4F7F5"/>
+                  <a:srgbClr val="071923"/>
                 </a:solidFill>
               </a:rPr>
               <a:t>Overview - Microsoft Copilot Studio</a:t>
@@ -2736,7 +3191,7 @@
             <a:r>
               <a:rPr lang="en-US" sz="1100">
                 <a:solidFill>
-                  <a:srgbClr val="B4B7B5"/>
+                  <a:srgbClr val="626C71"/>
                 </a:solidFill>
               </a:rPr>
               <a:t>  retrieved 2026-10-06</a:t>
@@ -2754,7 +3209,7 @@
             <a:r>
               <a:rPr lang="en-US" sz="1100">
                 <a:solidFill>
-                  <a:srgbClr val="55C2B8"/>
+                  <a:srgbClr val="006EC3"/>
                 </a:solidFill>
               </a:rPr>
               <a:t>https://learn.microsoft.com/en-us/microsoft-copilot-studio/fundamentals-what-is-copilot-studio</a:t>
@@ -2764,14 +3219,14 @@
       </p:sp>
       <p:sp>
         <p:nvSpPr>
-          <p:cNvPr id="5" name="Footer"/>
+          <p:cNvPr id="8" name="Footer"/>
           <p:cNvSpPr txBox="1"/>
           <p:nvPr/>
         </p:nvSpPr>
         <p:spPr>
           <a:xfrm>
             <a:off x="685800" y="6250000"/>
-            <a:ext cx="9400000" cy="420000"/>
+            <a:ext cx="10820400" cy="420000"/>
           </a:xfrm>
           <a:prstGeom prst="rect">
             <a:avLst/>
@@ -2798,47 +3253,10 @@
             <a:r>
               <a:rPr lang="en-US" sz="1000">
                 <a:solidFill>
-                  <a:srgbClr val="B4B7B5"/>
-                </a:solidFill>
-              </a:rPr>
-              <a:t>copilot-2026-09-am-michael-kokoro-onnx</a:t>
-            </a:r>
-          </a:p>
-        </p:txBody>
-      </p:sp>
-      <p:sp>
-        <p:nvSpPr>
-          <p:cNvPr id="6" name="Slide number"/>
-          <p:cNvSpPr txBox="1"/>
-          <p:nvPr/>
-        </p:nvSpPr>
-        <p:spPr>
-          <a:xfrm>
-            <a:off x="10100000" y="6250000"/>
-            <a:ext cx="1400000" cy="420000"/>
-          </a:xfrm>
-          <a:prstGeom prst="rect">
-            <a:avLst/>
-          </a:prstGeom>
-          <a:noFill/>
-          <a:ln>
-            <a:noFill/>
-          </a:ln>
-        </p:spPr>
-        <p:txBody>
-          <a:bodyPr wrap="square" lIns="182880" tIns="91440" rIns="182880" bIns="91440" anchor="t">
-            <a:normAutofit/>
-          </a:bodyPr>
-          <a:lstStyle/>
-          <a:p>
-            <a:pPr algn="r"/>
-            <a:r>
-              <a:rPr lang="en-US" sz="1000">
-                <a:solidFill>
-                  <a:srgbClr val="B4B7B5"/>
-                </a:solidFill>
-              </a:rPr>
-              <a:t>6 / 6</a:t>
+                  <a:srgbClr val="626C71"/>
+                </a:solidFill>
+              </a:rPr>
+              <a:t>copilot-2026-10-am-michael-kokoro-onnx</a:t>
             </a:r>
           </a:p>
         </p:txBody>
@@ -2852,59 +3270,59 @@
 </file>
 
 <file path=ppt/theme/theme1.xml><?xml version="1.0" encoding="utf-8"?>
-<a:theme xmlns:a="http://schemas.openxmlformats.org/drawingml/2006/main" name="refined-dark-neutral">
+<a:theme xmlns:a="http://schemas.openxmlformats.org/drawingml/2006/main" name="copilot-brand">
   <a:themeElements>
-    <a:clrScheme name="refined-dark-neutral">
+    <a:clrScheme name="copilot-brand">
       <a:dk1>
-        <a:srgbClr val="F4F7F5"/>
+        <a:srgbClr val="071923"/>
       </a:dk1>
       <a:lt1>
-        <a:srgbClr val="101312"/>
+        <a:srgbClr val="F4F8FC"/>
       </a:lt1>
       <a:dk2>
-        <a:srgbClr val="1F1F1F"/>
+        <a:srgbClr val="091F2C"/>
       </a:dk2>
       <a:lt2>
-        <a:srgbClr val="F8F8F8"/>
+        <a:srgbClr val="E6F1F9"/>
       </a:lt2>
       <a:accent1>
-        <a:srgbClr val="55C2B8"/>
+        <a:srgbClr val="006EC3"/>
       </a:accent1>
       <a:accent2>
-        <a:srgbClr val="5B9BD5"/>
+        <a:srgbClr val="50E6FF"/>
       </a:accent2>
       <a:accent3>
-        <a:srgbClr val="70AD47"/>
+        <a:srgbClr val="006EC3"/>
       </a:accent3>
       <a:accent4>
-        <a:srgbClr val="FFC000"/>
+        <a:srgbClr val="06141D"/>
       </a:accent4>
       <a:accent5>
-        <a:srgbClr val="C00000"/>
+        <a:srgbClr val="626C71"/>
       </a:accent5>
       <a:accent6>
-        <a:srgbClr val="7030A0"/>
+        <a:srgbClr val="B42318"/>
       </a:accent6>
       <a:hlink>
-        <a:srgbClr val="55C2B8"/>
+        <a:srgbClr val="006EC3"/>
       </a:hlink>
       <a:folHlink>
-        <a:srgbClr val="7F7F7F"/>
+        <a:srgbClr val="626C71"/>
       </a:folHlink>
     </a:clrScheme>
-    <a:fontScheme name="refined-dark-neutral">
+    <a:fontScheme name="copilot-brand">
       <a:majorFont>
-        <a:latin typeface="Arial"/>
+        <a:latin typeface="Segoe UI Variable Display"/>
         <a:ea typeface=""/>
         <a:cs typeface=""/>
       </a:majorFont>
       <a:minorFont>
-        <a:latin typeface="Arial"/>
+        <a:latin typeface="Segoe UI Variable Text"/>
         <a:ea typeface=""/>
         <a:cs typeface=""/>
       </a:minorFont>
     </a:fontScheme>
-    <a:fmtScheme name="refined-dark-neutral">
+    <a:fmtScheme name="copilot-brand">
       <a:fillStyleLst>
         <a:solidFill>
           <a:schemeClr val="phClr"/>

</xml_diff>

<commit_message>
feat: regenerate copilot on media adapter 13
- render four voices with source-seeded Excalidraw strokes
- add video and spatial spectrograms and internal/external alignment evidence

🎨 - Generated by Copilot

Co-authored-by: Copilot <223556219+Copilot@users.noreply.github.com>
</commit_message>
<xml_diff>
--- a/projects/copilot/release/outputs/deck.pptx
+++ b/projects/copilot/release/outputs/deck.pptx
@@ -1429,7 +1429,7 @@
                   <a:srgbClr val="626C71"/>
                 </a:solidFill>
               </a:rPr>
-              <a:t>copilot-2026-10-am-michael-kokoro-onnx</a:t>
+              <a:t>copilot-2026-11-am-michael-kokoro-onnx</a:t>
             </a:r>
           </a:p>
         </p:txBody>
@@ -3256,7 +3256,7 @@
                   <a:srgbClr val="626C71"/>
                 </a:solidFill>
               </a:rPr>
-              <a:t>copilot-2026-10-am-michael-kokoro-onnx</a:t>
+              <a:t>copilot-2026-11-am-michael-kokoro-onnx</a:t>
             </a:r>
           </a:p>
         </p:txBody>

</xml_diff>